<commit_message>
add finished marketmindz guided project
</commit_message>
<xml_diff>
--- a/marketmindz/design/marketmindz_design.pptx
+++ b/marketmindz/design/marketmindz_design.pptx
@@ -200,7 +200,7 @@
           <a:p>
             <a:fld id="{B13B6F53-92C8-4509-9F1A-55492588CC3C}" type="datetimeFigureOut">
               <a:rPr lang="en-FI" smtClean="0"/>
-              <a:t>04/10/2025</a:t>
+              <a:t>05/10/2025</a:t>
             </a:fld>
             <a:endParaRPr lang="en-FI"/>
           </a:p>
@@ -1180,7 +1180,7 @@
           <a:p>
             <a:fld id="{9B968DEF-A3FA-4F7F-BC5F-EC77099FD92D}" type="datetimeFigureOut">
               <a:rPr lang="en-FI" smtClean="0"/>
-              <a:t>04/10/2025</a:t>
+              <a:t>05/10/2025</a:t>
             </a:fld>
             <a:endParaRPr lang="en-FI"/>
           </a:p>
@@ -1461,7 +1461,7 @@
           <a:p>
             <a:fld id="{9B968DEF-A3FA-4F7F-BC5F-EC77099FD92D}" type="datetimeFigureOut">
               <a:rPr lang="en-FI" smtClean="0"/>
-              <a:t>04/10/2025</a:t>
+              <a:t>05/10/2025</a:t>
             </a:fld>
             <a:endParaRPr lang="en-FI"/>
           </a:p>
@@ -1653,7 +1653,7 @@
           <a:p>
             <a:fld id="{9B968DEF-A3FA-4F7F-BC5F-EC77099FD92D}" type="datetimeFigureOut">
               <a:rPr lang="en-FI" smtClean="0"/>
-              <a:t>04/10/2025</a:t>
+              <a:t>05/10/2025</a:t>
             </a:fld>
             <a:endParaRPr lang="en-FI"/>
           </a:p>
@@ -1914,7 +1914,7 @@
           <a:p>
             <a:fld id="{9B968DEF-A3FA-4F7F-BC5F-EC77099FD92D}" type="datetimeFigureOut">
               <a:rPr lang="en-FI" smtClean="0"/>
-              <a:t>04/10/2025</a:t>
+              <a:t>05/10/2025</a:t>
             </a:fld>
             <a:endParaRPr lang="en-FI"/>
           </a:p>
@@ -2340,7 +2340,7 @@
           <a:p>
             <a:fld id="{9B968DEF-A3FA-4F7F-BC5F-EC77099FD92D}" type="datetimeFigureOut">
               <a:rPr lang="en-FI" smtClean="0"/>
-              <a:t>04/10/2025</a:t>
+              <a:t>05/10/2025</a:t>
             </a:fld>
             <a:endParaRPr lang="en-FI"/>
           </a:p>
@@ -2886,7 +2886,7 @@
           <a:p>
             <a:fld id="{9B968DEF-A3FA-4F7F-BC5F-EC77099FD92D}" type="datetimeFigureOut">
               <a:rPr lang="en-FI" smtClean="0"/>
-              <a:t>04/10/2025</a:t>
+              <a:t>05/10/2025</a:t>
             </a:fld>
             <a:endParaRPr lang="en-FI"/>
           </a:p>
@@ -3717,7 +3717,7 @@
           <a:p>
             <a:fld id="{9B968DEF-A3FA-4F7F-BC5F-EC77099FD92D}" type="datetimeFigureOut">
               <a:rPr lang="en-FI" smtClean="0"/>
-              <a:t>04/10/2025</a:t>
+              <a:t>05/10/2025</a:t>
             </a:fld>
             <a:endParaRPr lang="en-FI"/>
           </a:p>
@@ -3887,7 +3887,7 @@
           <a:p>
             <a:fld id="{9B968DEF-A3FA-4F7F-BC5F-EC77099FD92D}" type="datetimeFigureOut">
               <a:rPr lang="en-FI" smtClean="0"/>
-              <a:t>04/10/2025</a:t>
+              <a:t>05/10/2025</a:t>
             </a:fld>
             <a:endParaRPr lang="en-FI"/>
           </a:p>
@@ -4067,7 +4067,7 @@
           <a:p>
             <a:fld id="{9B968DEF-A3FA-4F7F-BC5F-EC77099FD92D}" type="datetimeFigureOut">
               <a:rPr lang="en-FI" smtClean="0"/>
-              <a:t>04/10/2025</a:t>
+              <a:t>05/10/2025</a:t>
             </a:fld>
             <a:endParaRPr lang="en-FI"/>
           </a:p>
@@ -4237,7 +4237,7 @@
           <a:p>
             <a:fld id="{9B968DEF-A3FA-4F7F-BC5F-EC77099FD92D}" type="datetimeFigureOut">
               <a:rPr lang="en-FI" smtClean="0"/>
-              <a:t>04/10/2025</a:t>
+              <a:t>05/10/2025</a:t>
             </a:fld>
             <a:endParaRPr lang="en-FI"/>
           </a:p>
@@ -4494,7 +4494,7 @@
           <a:p>
             <a:fld id="{9B968DEF-A3FA-4F7F-BC5F-EC77099FD92D}" type="datetimeFigureOut">
               <a:rPr lang="en-FI" smtClean="0"/>
-              <a:t>04/10/2025</a:t>
+              <a:t>05/10/2025</a:t>
             </a:fld>
             <a:endParaRPr lang="en-FI"/>
           </a:p>
@@ -4726,7 +4726,7 @@
           <a:p>
             <a:fld id="{9B968DEF-A3FA-4F7F-BC5F-EC77099FD92D}" type="datetimeFigureOut">
               <a:rPr lang="en-FI" smtClean="0"/>
-              <a:t>04/10/2025</a:t>
+              <a:t>05/10/2025</a:t>
             </a:fld>
             <a:endParaRPr lang="en-FI"/>
           </a:p>
@@ -5119,7 +5119,7 @@
           <a:p>
             <a:fld id="{9B968DEF-A3FA-4F7F-BC5F-EC77099FD92D}" type="datetimeFigureOut">
               <a:rPr lang="en-FI" smtClean="0"/>
-              <a:t>04/10/2025</a:t>
+              <a:t>05/10/2025</a:t>
             </a:fld>
             <a:endParaRPr lang="en-FI"/>
           </a:p>
@@ -5237,7 +5237,7 @@
           <a:p>
             <a:fld id="{9B968DEF-A3FA-4F7F-BC5F-EC77099FD92D}" type="datetimeFigureOut">
               <a:rPr lang="en-FI" smtClean="0"/>
-              <a:t>04/10/2025</a:t>
+              <a:t>05/10/2025</a:t>
             </a:fld>
             <a:endParaRPr lang="en-FI"/>
           </a:p>
@@ -5332,7 +5332,7 @@
           <a:p>
             <a:fld id="{9B968DEF-A3FA-4F7F-BC5F-EC77099FD92D}" type="datetimeFigureOut">
               <a:rPr lang="en-FI" smtClean="0"/>
-              <a:t>04/10/2025</a:t>
+              <a:t>05/10/2025</a:t>
             </a:fld>
             <a:endParaRPr lang="en-FI"/>
           </a:p>
@@ -5605,7 +5605,7 @@
           <a:p>
             <a:fld id="{9B968DEF-A3FA-4F7F-BC5F-EC77099FD92D}" type="datetimeFigureOut">
               <a:rPr lang="en-FI" smtClean="0"/>
-              <a:t>04/10/2025</a:t>
+              <a:t>05/10/2025</a:t>
             </a:fld>
             <a:endParaRPr lang="en-FI"/>
           </a:p>
@@ -5886,7 +5886,7 @@
           <a:p>
             <a:fld id="{9B968DEF-A3FA-4F7F-BC5F-EC77099FD92D}" type="datetimeFigureOut">
               <a:rPr lang="en-FI" smtClean="0"/>
-              <a:t>04/10/2025</a:t>
+              <a:t>05/10/2025</a:t>
             </a:fld>
             <a:endParaRPr lang="en-FI"/>
           </a:p>
@@ -6126,7 +6126,7 @@
           <a:p>
             <a:fld id="{9B968DEF-A3FA-4F7F-BC5F-EC77099FD92D}" type="datetimeFigureOut">
               <a:rPr lang="en-FI" smtClean="0"/>
-              <a:t>04/10/2025</a:t>
+              <a:t>05/10/2025</a:t>
             </a:fld>
             <a:endParaRPr lang="en-FI"/>
           </a:p>
@@ -6813,9 +6813,13 @@
           <a:bodyPr rtlCol="0" anchor="ctr"/>
           <a:lstStyle/>
           <a:p>
-            <a:pPr algn="r"/>
+            <a:pPr algn="r">
+              <a:lnSpc>
+                <a:spcPct val="150000"/>
+              </a:lnSpc>
+            </a:pPr>
             <a:r>
-              <a:rPr lang="en-US" sz="1600" spc="300" dirty="0">
+              <a:rPr lang="en-US" sz="1400" spc="300" dirty="0">
                 <a:effectLst>
                   <a:outerShdw blurRad="50800" dist="38100" dir="2700000" algn="tl" rotWithShape="0">
                     <a:prstClr val="black">
@@ -6824,10 +6828,22 @@
                   </a:outerShdw>
                 </a:effectLst>
               </a:rPr>
-              <a:t>Developed by </a:t>
+              <a:t>Developed by Toni Sundqvist</a:t>
             </a:r>
+            <a:endParaRPr lang="en-FI" sz="1400" spc="300" dirty="0">
+              <a:effectLst>
+                <a:outerShdw blurRad="50800" dist="38100" dir="2700000" algn="tl" rotWithShape="0">
+                  <a:prstClr val="black">
+                    <a:alpha val="40000"/>
+                  </a:prstClr>
+                </a:outerShdw>
+              </a:effectLst>
+            </a:endParaRPr>
+          </a:p>
+          <a:p>
+            <a:pPr algn="r"/>
             <a:r>
-              <a:rPr lang="en-US" sz="1600" spc="300" dirty="0" err="1">
+              <a:rPr lang="en-US" sz="900" spc="300" dirty="0">
                 <a:effectLst>
                   <a:outerShdw blurRad="50800" dist="38100" dir="2700000" algn="tl" rotWithShape="0">
                     <a:prstClr val="black">
@@ -6836,17 +6852,8 @@
                   </a:outerShdw>
                 </a:effectLst>
               </a:rPr>
-              <a:t>Sunkken</a:t>
+              <a:t>Guided Project by Sean Chandler</a:t>
             </a:r>
-            <a:endParaRPr lang="en-FI" sz="1600" spc="300" dirty="0">
-              <a:effectLst>
-                <a:outerShdw blurRad="50800" dist="38100" dir="2700000" algn="tl" rotWithShape="0">
-                  <a:prstClr val="black">
-                    <a:alpha val="40000"/>
-                  </a:prstClr>
-                </a:outerShdw>
-              </a:effectLst>
-            </a:endParaRPr>
           </a:p>
         </p:txBody>
       </p:sp>
@@ -7821,7 +7828,7 @@
           <a:p>
             <a:pPr marL="0" marR="0" lvl="0" indent="0" algn="r" defTabSz="457200" rtl="0" eaLnBrk="1" fontAlgn="auto" latinLnBrk="0" hangingPunct="1">
               <a:lnSpc>
-                <a:spcPct val="100000"/>
+                <a:spcPct val="150000"/>
               </a:lnSpc>
               <a:spcBef>
                 <a:spcPts val="0"/>
@@ -7837,7 +7844,7 @@
               <a:defRPr/>
             </a:pPr>
             <a:r>
-              <a:rPr kumimoji="0" lang="en-US" sz="1600" b="0" i="0" u="none" strike="noStrike" kern="1200" cap="none" spc="300" normalizeH="0" baseline="0" noProof="0" dirty="0">
+              <a:rPr kumimoji="0" lang="en-US" sz="1400" b="0" i="0" u="none" strike="noStrike" kern="1200" cap="none" spc="300" normalizeH="0" baseline="0" noProof="0" dirty="0">
                 <a:ln>
                   <a:noFill/>
                 </a:ln>
@@ -7857,10 +7864,49 @@
                 <a:ea typeface="+mn-ea"/>
                 <a:cs typeface="+mn-cs"/>
               </a:rPr>
-              <a:t>Developed by </a:t>
+              <a:t>Developed by Toni Sundqvist</a:t>
             </a:r>
+            <a:endParaRPr kumimoji="0" lang="en-FI" sz="1400" b="0" i="0" u="none" strike="noStrike" kern="1200" cap="none" spc="300" normalizeH="0" baseline="0" noProof="0" dirty="0">
+              <a:ln>
+                <a:noFill/>
+              </a:ln>
+              <a:solidFill>
+                <a:prstClr val="white"/>
+              </a:solidFill>
+              <a:effectLst>
+                <a:outerShdw blurRad="50800" dist="38100" dir="2700000" algn="tl" rotWithShape="0">
+                  <a:prstClr val="black">
+                    <a:alpha val="40000"/>
+                  </a:prstClr>
+                </a:outerShdw>
+              </a:effectLst>
+              <a:uLnTx/>
+              <a:uFillTx/>
+              <a:latin typeface="Corbel" panose="020B0503020204020204"/>
+              <a:ea typeface="+mn-ea"/>
+              <a:cs typeface="+mn-cs"/>
+            </a:endParaRPr>
+          </a:p>
+          <a:p>
+            <a:pPr marL="0" marR="0" lvl="0" indent="0" algn="r" defTabSz="457200" rtl="0" eaLnBrk="1" fontAlgn="auto" latinLnBrk="0" hangingPunct="1">
+              <a:lnSpc>
+                <a:spcPct val="100000"/>
+              </a:lnSpc>
+              <a:spcBef>
+                <a:spcPts val="0"/>
+              </a:spcBef>
+              <a:spcAft>
+                <a:spcPts val="0"/>
+              </a:spcAft>
+              <a:buClrTx/>
+              <a:buSzTx/>
+              <a:buFontTx/>
+              <a:buNone/>
+              <a:tabLst/>
+              <a:defRPr/>
+            </a:pPr>
             <a:r>
-              <a:rPr kumimoji="0" lang="en-US" sz="1600" b="0" i="0" u="none" strike="noStrike" kern="1200" cap="none" spc="300" normalizeH="0" baseline="0" noProof="0" dirty="0" err="1">
+              <a:rPr kumimoji="0" lang="en-US" sz="900" b="0" i="0" u="none" strike="noStrike" kern="1200" cap="none" spc="300" normalizeH="0" baseline="0" noProof="0" dirty="0">
                 <a:ln>
                   <a:noFill/>
                 </a:ln>
@@ -7880,28 +7926,8 @@
                 <a:ea typeface="+mn-ea"/>
                 <a:cs typeface="+mn-cs"/>
               </a:rPr>
-              <a:t>Sunkken</a:t>
+              <a:t>Guided Project by Sean Chandler</a:t>
             </a:r>
-            <a:endParaRPr kumimoji="0" lang="en-FI" sz="1600" b="0" i="0" u="none" strike="noStrike" kern="1200" cap="none" spc="300" normalizeH="0" baseline="0" noProof="0" dirty="0">
-              <a:ln>
-                <a:noFill/>
-              </a:ln>
-              <a:solidFill>
-                <a:prstClr val="white"/>
-              </a:solidFill>
-              <a:effectLst>
-                <a:outerShdw blurRad="50800" dist="38100" dir="2700000" algn="tl" rotWithShape="0">
-                  <a:prstClr val="black">
-                    <a:alpha val="40000"/>
-                  </a:prstClr>
-                </a:outerShdw>
-              </a:effectLst>
-              <a:uLnTx/>
-              <a:uFillTx/>
-              <a:latin typeface="Corbel" panose="020B0503020204020204"/>
-              <a:ea typeface="+mn-ea"/>
-              <a:cs typeface="+mn-cs"/>
-            </a:endParaRPr>
           </a:p>
         </p:txBody>
       </p:sp>
@@ -9097,7 +9123,7 @@
           <a:p>
             <a:pPr marL="0" marR="0" lvl="0" indent="0" algn="r" defTabSz="457200" rtl="0" eaLnBrk="1" fontAlgn="auto" latinLnBrk="0" hangingPunct="1">
               <a:lnSpc>
-                <a:spcPct val="100000"/>
+                <a:spcPct val="150000"/>
               </a:lnSpc>
               <a:spcBef>
                 <a:spcPts val="0"/>
@@ -9113,7 +9139,7 @@
               <a:defRPr/>
             </a:pPr>
             <a:r>
-              <a:rPr kumimoji="0" lang="en-US" sz="1600" b="0" i="0" u="none" strike="noStrike" kern="1200" cap="none" spc="300" normalizeH="0" baseline="0" noProof="0" dirty="0">
+              <a:rPr kumimoji="0" lang="en-US" sz="1400" b="0" i="0" u="none" strike="noStrike" kern="1200" cap="none" spc="300" normalizeH="0" baseline="0" noProof="0" dirty="0">
                 <a:ln>
                   <a:noFill/>
                 </a:ln>
@@ -9133,10 +9159,49 @@
                 <a:ea typeface="+mn-ea"/>
                 <a:cs typeface="+mn-cs"/>
               </a:rPr>
-              <a:t>Developed by </a:t>
+              <a:t>Developed by Toni Sundqvist</a:t>
             </a:r>
+            <a:endParaRPr kumimoji="0" lang="en-FI" sz="1400" b="0" i="0" u="none" strike="noStrike" kern="1200" cap="none" spc="300" normalizeH="0" baseline="0" noProof="0" dirty="0">
+              <a:ln>
+                <a:noFill/>
+              </a:ln>
+              <a:solidFill>
+                <a:prstClr val="white"/>
+              </a:solidFill>
+              <a:effectLst>
+                <a:outerShdw blurRad="50800" dist="38100" dir="2700000" algn="tl" rotWithShape="0">
+                  <a:prstClr val="black">
+                    <a:alpha val="40000"/>
+                  </a:prstClr>
+                </a:outerShdw>
+              </a:effectLst>
+              <a:uLnTx/>
+              <a:uFillTx/>
+              <a:latin typeface="Corbel" panose="020B0503020204020204"/>
+              <a:ea typeface="+mn-ea"/>
+              <a:cs typeface="+mn-cs"/>
+            </a:endParaRPr>
+          </a:p>
+          <a:p>
+            <a:pPr marL="0" marR="0" lvl="0" indent="0" algn="r" defTabSz="457200" rtl="0" eaLnBrk="1" fontAlgn="auto" latinLnBrk="0" hangingPunct="1">
+              <a:lnSpc>
+                <a:spcPct val="100000"/>
+              </a:lnSpc>
+              <a:spcBef>
+                <a:spcPts val="0"/>
+              </a:spcBef>
+              <a:spcAft>
+                <a:spcPts val="0"/>
+              </a:spcAft>
+              <a:buClrTx/>
+              <a:buSzTx/>
+              <a:buFontTx/>
+              <a:buNone/>
+              <a:tabLst/>
+              <a:defRPr/>
+            </a:pPr>
             <a:r>
-              <a:rPr kumimoji="0" lang="en-US" sz="1600" b="0" i="0" u="none" strike="noStrike" kern="1200" cap="none" spc="300" normalizeH="0" baseline="0" noProof="0" dirty="0" err="1">
+              <a:rPr kumimoji="0" lang="en-US" sz="900" b="0" i="0" u="none" strike="noStrike" kern="1200" cap="none" spc="300" normalizeH="0" baseline="0" noProof="0" dirty="0">
                 <a:ln>
                   <a:noFill/>
                 </a:ln>
@@ -9156,28 +9221,8 @@
                 <a:ea typeface="+mn-ea"/>
                 <a:cs typeface="+mn-cs"/>
               </a:rPr>
-              <a:t>Sunkken</a:t>
+              <a:t>Guided Project by Sean Chandler</a:t>
             </a:r>
-            <a:endParaRPr kumimoji="0" lang="en-FI" sz="1600" b="0" i="0" u="none" strike="noStrike" kern="1200" cap="none" spc="300" normalizeH="0" baseline="0" noProof="0" dirty="0">
-              <a:ln>
-                <a:noFill/>
-              </a:ln>
-              <a:solidFill>
-                <a:prstClr val="white"/>
-              </a:solidFill>
-              <a:effectLst>
-                <a:outerShdw blurRad="50800" dist="38100" dir="2700000" algn="tl" rotWithShape="0">
-                  <a:prstClr val="black">
-                    <a:alpha val="40000"/>
-                  </a:prstClr>
-                </a:outerShdw>
-              </a:effectLst>
-              <a:uLnTx/>
-              <a:uFillTx/>
-              <a:latin typeface="Corbel" panose="020B0503020204020204"/>
-              <a:ea typeface="+mn-ea"/>
-              <a:cs typeface="+mn-cs"/>
-            </a:endParaRPr>
           </a:p>
         </p:txBody>
       </p:sp>
@@ -10859,6 +10904,350 @@
         <p:spPr>
           <a:xfrm>
             <a:off x="9269017" y="2726315"/>
+            <a:ext cx="914400" cy="914400"/>
+          </a:xfrm>
+          <a:prstGeom prst="rect">
+            <a:avLst/>
+          </a:prstGeom>
+          <a:effectLst>
+            <a:outerShdw blurRad="50800" dist="38100" dir="2700000" algn="tl" rotWithShape="0">
+              <a:prstClr val="black">
+                <a:alpha val="40000"/>
+              </a:prstClr>
+            </a:outerShdw>
+          </a:effectLst>
+        </p:spPr>
+      </p:pic>
+      <p:pic>
+        <p:nvPicPr>
+          <p:cNvPr id="2" name="Graphic 1" descr="Monthly calendar with solid fill">
+            <a:extLst>
+              <a:ext uri="{FF2B5EF4-FFF2-40B4-BE49-F238E27FC236}">
+                <a16:creationId xmlns:a16="http://schemas.microsoft.com/office/drawing/2014/main" id="{A8224B8E-B963-E6CF-5043-017A21407116}"/>
+              </a:ext>
+            </a:extLst>
+          </p:cNvPr>
+          <p:cNvPicPr>
+            <a:picLocks noChangeAspect="1"/>
+          </p:cNvPicPr>
+          <p:nvPr/>
+        </p:nvPicPr>
+        <p:blipFill>
+          <a:blip r:embed="rId15">
+            <a:extLst>
+              <a:ext uri="{96DAC541-7B7A-43D3-8B79-37D633B846F1}">
+                <asvg:svgBlip xmlns:asvg="http://schemas.microsoft.com/office/drawing/2016/SVG/main" r:embed="rId16"/>
+              </a:ext>
+            </a:extLst>
+          </a:blip>
+          <a:stretch>
+            <a:fillRect/>
+          </a:stretch>
+        </p:blipFill>
+        <p:spPr>
+          <a:xfrm>
+            <a:off x="1796143" y="4836943"/>
+            <a:ext cx="914400" cy="914400"/>
+          </a:xfrm>
+          <a:prstGeom prst="rect">
+            <a:avLst/>
+          </a:prstGeom>
+          <a:effectLst>
+            <a:outerShdw blurRad="50800" dist="38100" dir="2700000" algn="tl" rotWithShape="0">
+              <a:prstClr val="black">
+                <a:alpha val="40000"/>
+              </a:prstClr>
+            </a:outerShdw>
+          </a:effectLst>
+        </p:spPr>
+      </p:pic>
+      <p:pic>
+        <p:nvPicPr>
+          <p:cNvPr id="3" name="Graphic 2" descr="Internet with solid fill">
+            <a:extLst>
+              <a:ext uri="{FF2B5EF4-FFF2-40B4-BE49-F238E27FC236}">
+                <a16:creationId xmlns:a16="http://schemas.microsoft.com/office/drawing/2014/main" id="{0E4AC2F8-D321-7B90-A14D-9FC19EDFDA85}"/>
+              </a:ext>
+            </a:extLst>
+          </p:cNvPr>
+          <p:cNvPicPr>
+            <a:picLocks noChangeAspect="1"/>
+          </p:cNvPicPr>
+          <p:nvPr/>
+        </p:nvPicPr>
+        <p:blipFill>
+          <a:blip r:embed="rId17">
+            <a:extLst>
+              <a:ext uri="{96DAC541-7B7A-43D3-8B79-37D633B846F1}">
+                <asvg:svgBlip xmlns:asvg="http://schemas.microsoft.com/office/drawing/2016/SVG/main" r:embed="rId18"/>
+              </a:ext>
+            </a:extLst>
+          </a:blip>
+          <a:stretch>
+            <a:fillRect/>
+          </a:stretch>
+        </p:blipFill>
+        <p:spPr>
+          <a:xfrm>
+            <a:off x="2921983" y="4836943"/>
+            <a:ext cx="914400" cy="914400"/>
+          </a:xfrm>
+          <a:prstGeom prst="rect">
+            <a:avLst/>
+          </a:prstGeom>
+          <a:effectLst>
+            <a:outerShdw blurRad="50800" dist="38100" dir="2700000" algn="tl" rotWithShape="0">
+              <a:prstClr val="black">
+                <a:alpha val="40000"/>
+              </a:prstClr>
+            </a:outerShdw>
+          </a:effectLst>
+        </p:spPr>
+      </p:pic>
+      <p:pic>
+        <p:nvPicPr>
+          <p:cNvPr id="13" name="Graphic 12" descr="Open book with solid fill">
+            <a:extLst>
+              <a:ext uri="{FF2B5EF4-FFF2-40B4-BE49-F238E27FC236}">
+                <a16:creationId xmlns:a16="http://schemas.microsoft.com/office/drawing/2014/main" id="{3B761526-C309-A5D5-3EED-D9DE317E8163}"/>
+              </a:ext>
+            </a:extLst>
+          </p:cNvPr>
+          <p:cNvPicPr>
+            <a:picLocks noChangeAspect="1"/>
+          </p:cNvPicPr>
+          <p:nvPr/>
+        </p:nvPicPr>
+        <p:blipFill>
+          <a:blip r:embed="rId19">
+            <a:extLst>
+              <a:ext uri="{96DAC541-7B7A-43D3-8B79-37D633B846F1}">
+                <asvg:svgBlip xmlns:asvg="http://schemas.microsoft.com/office/drawing/2016/SVG/main" r:embed="rId20"/>
+              </a:ext>
+            </a:extLst>
+          </a:blip>
+          <a:stretch>
+            <a:fillRect/>
+          </a:stretch>
+        </p:blipFill>
+        <p:spPr>
+          <a:xfrm>
+            <a:off x="4047823" y="4836943"/>
+            <a:ext cx="914400" cy="914400"/>
+          </a:xfrm>
+          <a:prstGeom prst="rect">
+            <a:avLst/>
+          </a:prstGeom>
+          <a:effectLst>
+            <a:outerShdw blurRad="50800" dist="38100" dir="2700000" algn="tl" rotWithShape="0">
+              <a:prstClr val="black">
+                <a:alpha val="40000"/>
+              </a:prstClr>
+            </a:outerShdw>
+          </a:effectLst>
+        </p:spPr>
+      </p:pic>
+      <p:pic>
+        <p:nvPicPr>
+          <p:cNvPr id="21" name="Graphic 20" descr="Kiosk with solid fill">
+            <a:extLst>
+              <a:ext uri="{FF2B5EF4-FFF2-40B4-BE49-F238E27FC236}">
+                <a16:creationId xmlns:a16="http://schemas.microsoft.com/office/drawing/2014/main" id="{AC09D1F7-7476-6F8D-BAC2-95A4E6A36EBB}"/>
+              </a:ext>
+            </a:extLst>
+          </p:cNvPr>
+          <p:cNvPicPr>
+            <a:picLocks noChangeAspect="1"/>
+          </p:cNvPicPr>
+          <p:nvPr/>
+        </p:nvPicPr>
+        <p:blipFill>
+          <a:blip r:embed="rId21">
+            <a:extLst>
+              <a:ext uri="{96DAC541-7B7A-43D3-8B79-37D633B846F1}">
+                <asvg:svgBlip xmlns:asvg="http://schemas.microsoft.com/office/drawing/2016/SVG/main" r:embed="rId22"/>
+              </a:ext>
+            </a:extLst>
+          </a:blip>
+          <a:stretch>
+            <a:fillRect/>
+          </a:stretch>
+        </p:blipFill>
+        <p:spPr>
+          <a:xfrm>
+            <a:off x="5173663" y="4836943"/>
+            <a:ext cx="914400" cy="914400"/>
+          </a:xfrm>
+          <a:prstGeom prst="rect">
+            <a:avLst/>
+          </a:prstGeom>
+          <a:effectLst>
+            <a:outerShdw blurRad="50800" dist="38100" dir="2700000" algn="tl" rotWithShape="0">
+              <a:prstClr val="black">
+                <a:alpha val="40000"/>
+              </a:prstClr>
+            </a:outerShdw>
+          </a:effectLst>
+        </p:spPr>
+      </p:pic>
+      <p:pic>
+        <p:nvPicPr>
+          <p:cNvPr id="12" name="Graphic 11" descr="Money with solid fill">
+            <a:extLst>
+              <a:ext uri="{FF2B5EF4-FFF2-40B4-BE49-F238E27FC236}">
+                <a16:creationId xmlns:a16="http://schemas.microsoft.com/office/drawing/2014/main" id="{0E3FF502-1829-66C6-C3E7-4C305A6A0CE0}"/>
+              </a:ext>
+            </a:extLst>
+          </p:cNvPr>
+          <p:cNvPicPr>
+            <a:picLocks noChangeAspect="1"/>
+          </p:cNvPicPr>
+          <p:nvPr/>
+        </p:nvPicPr>
+        <p:blipFill>
+          <a:blip r:embed="rId23">
+            <a:extLst>
+              <a:ext uri="{96DAC541-7B7A-43D3-8B79-37D633B846F1}">
+                <asvg:svgBlip xmlns:asvg="http://schemas.microsoft.com/office/drawing/2016/SVG/main" r:embed="rId24"/>
+              </a:ext>
+            </a:extLst>
+          </a:blip>
+          <a:stretch>
+            <a:fillRect/>
+          </a:stretch>
+        </p:blipFill>
+        <p:spPr>
+          <a:xfrm>
+            <a:off x="6299503" y="4836943"/>
+            <a:ext cx="914400" cy="914400"/>
+          </a:xfrm>
+          <a:prstGeom prst="rect">
+            <a:avLst/>
+          </a:prstGeom>
+          <a:effectLst>
+            <a:outerShdw blurRad="50800" dist="38100" dir="2700000" algn="tl" rotWithShape="0">
+              <a:prstClr val="black">
+                <a:alpha val="40000"/>
+              </a:prstClr>
+            </a:outerShdw>
+          </a:effectLst>
+        </p:spPr>
+      </p:pic>
+      <p:pic>
+        <p:nvPicPr>
+          <p:cNvPr id="14" name="Graphic 13" descr="Piggy Bank with solid fill">
+            <a:extLst>
+              <a:ext uri="{FF2B5EF4-FFF2-40B4-BE49-F238E27FC236}">
+                <a16:creationId xmlns:a16="http://schemas.microsoft.com/office/drawing/2014/main" id="{48786D49-B914-AA84-AD48-6D8BABCD3AF3}"/>
+              </a:ext>
+            </a:extLst>
+          </p:cNvPr>
+          <p:cNvPicPr>
+            <a:picLocks noChangeAspect="1"/>
+          </p:cNvPicPr>
+          <p:nvPr/>
+        </p:nvPicPr>
+        <p:blipFill>
+          <a:blip r:embed="rId25">
+            <a:extLst>
+              <a:ext uri="{96DAC541-7B7A-43D3-8B79-37D633B846F1}">
+                <asvg:svgBlip xmlns:asvg="http://schemas.microsoft.com/office/drawing/2016/SVG/main" r:embed="rId26"/>
+              </a:ext>
+            </a:extLst>
+          </a:blip>
+          <a:stretch>
+            <a:fillRect/>
+          </a:stretch>
+        </p:blipFill>
+        <p:spPr>
+          <a:xfrm>
+            <a:off x="7425343" y="4836943"/>
+            <a:ext cx="914400" cy="914400"/>
+          </a:xfrm>
+          <a:prstGeom prst="rect">
+            <a:avLst/>
+          </a:prstGeom>
+          <a:effectLst>
+            <a:outerShdw blurRad="50800" dist="38100" dir="2700000" algn="tl" rotWithShape="0">
+              <a:prstClr val="black">
+                <a:alpha val="40000"/>
+              </a:prstClr>
+            </a:outerShdw>
+          </a:effectLst>
+        </p:spPr>
+      </p:pic>
+      <p:pic>
+        <p:nvPicPr>
+          <p:cNvPr id="15" name="Graphic 14" descr="Man with cane with solid fill">
+            <a:extLst>
+              <a:ext uri="{FF2B5EF4-FFF2-40B4-BE49-F238E27FC236}">
+                <a16:creationId xmlns:a16="http://schemas.microsoft.com/office/drawing/2014/main" id="{08E8BA0B-5BDA-2BA1-C6D6-75D2EC32C1E6}"/>
+              </a:ext>
+            </a:extLst>
+          </p:cNvPr>
+          <p:cNvPicPr>
+            <a:picLocks noChangeAspect="1"/>
+          </p:cNvPicPr>
+          <p:nvPr/>
+        </p:nvPicPr>
+        <p:blipFill>
+          <a:blip r:embed="rId27">
+            <a:extLst>
+              <a:ext uri="{96DAC541-7B7A-43D3-8B79-37D633B846F1}">
+                <asvg:svgBlip xmlns:asvg="http://schemas.microsoft.com/office/drawing/2016/SVG/main" r:embed="rId28"/>
+              </a:ext>
+            </a:extLst>
+          </a:blip>
+          <a:stretch>
+            <a:fillRect/>
+          </a:stretch>
+        </p:blipFill>
+        <p:spPr>
+          <a:xfrm>
+            <a:off x="8551183" y="4836943"/>
+            <a:ext cx="914400" cy="914400"/>
+          </a:xfrm>
+          <a:prstGeom prst="rect">
+            <a:avLst/>
+          </a:prstGeom>
+          <a:effectLst>
+            <a:outerShdw blurRad="50800" dist="38100" dir="2700000" algn="tl" rotWithShape="0">
+              <a:prstClr val="black">
+                <a:alpha val="40000"/>
+              </a:prstClr>
+            </a:outerShdw>
+          </a:effectLst>
+        </p:spPr>
+      </p:pic>
+      <p:pic>
+        <p:nvPicPr>
+          <p:cNvPr id="16" name="Graphic 15" descr="Group with solid fill">
+            <a:extLst>
+              <a:ext uri="{FF2B5EF4-FFF2-40B4-BE49-F238E27FC236}">
+                <a16:creationId xmlns:a16="http://schemas.microsoft.com/office/drawing/2014/main" id="{DC0CC964-486E-A212-7618-7E2000C4A69B}"/>
+              </a:ext>
+            </a:extLst>
+          </p:cNvPr>
+          <p:cNvPicPr>
+            <a:picLocks noChangeAspect="1"/>
+          </p:cNvPicPr>
+          <p:nvPr/>
+        </p:nvPicPr>
+        <p:blipFill>
+          <a:blip r:embed="rId29">
+            <a:extLst>
+              <a:ext uri="{96DAC541-7B7A-43D3-8B79-37D633B846F1}">
+                <asvg:svgBlip xmlns:asvg="http://schemas.microsoft.com/office/drawing/2016/SVG/main" r:embed="rId30"/>
+              </a:ext>
+            </a:extLst>
+          </a:blip>
+          <a:stretch>
+            <a:fillRect/>
+          </a:stretch>
+        </p:blipFill>
+        <p:spPr>
+          <a:xfrm>
+            <a:off x="9677022" y="4836943"/>
             <a:ext cx="914400" cy="914400"/>
           </a:xfrm>
           <a:prstGeom prst="rect">

</xml_diff>

<commit_message>
Add krakenkoffee Part 1. (also marketmindz bg signature change)
</commit_message>
<xml_diff>
--- a/marketmindz/design/marketmindz_design.pptx
+++ b/marketmindz/design/marketmindz_design.pptx
@@ -200,7 +200,7 @@
           <a:p>
             <a:fld id="{B13B6F53-92C8-4509-9F1A-55492588CC3C}" type="datetimeFigureOut">
               <a:rPr lang="en-FI" smtClean="0"/>
-              <a:t>05/10/2025</a:t>
+              <a:t>06/10/2025</a:t>
             </a:fld>
             <a:endParaRPr lang="en-FI"/>
           </a:p>
@@ -1180,7 +1180,7 @@
           <a:p>
             <a:fld id="{9B968DEF-A3FA-4F7F-BC5F-EC77099FD92D}" type="datetimeFigureOut">
               <a:rPr lang="en-FI" smtClean="0"/>
-              <a:t>05/10/2025</a:t>
+              <a:t>06/10/2025</a:t>
             </a:fld>
             <a:endParaRPr lang="en-FI"/>
           </a:p>
@@ -1461,7 +1461,7 @@
           <a:p>
             <a:fld id="{9B968DEF-A3FA-4F7F-BC5F-EC77099FD92D}" type="datetimeFigureOut">
               <a:rPr lang="en-FI" smtClean="0"/>
-              <a:t>05/10/2025</a:t>
+              <a:t>06/10/2025</a:t>
             </a:fld>
             <a:endParaRPr lang="en-FI"/>
           </a:p>
@@ -1653,7 +1653,7 @@
           <a:p>
             <a:fld id="{9B968DEF-A3FA-4F7F-BC5F-EC77099FD92D}" type="datetimeFigureOut">
               <a:rPr lang="en-FI" smtClean="0"/>
-              <a:t>05/10/2025</a:t>
+              <a:t>06/10/2025</a:t>
             </a:fld>
             <a:endParaRPr lang="en-FI"/>
           </a:p>
@@ -1914,7 +1914,7 @@
           <a:p>
             <a:fld id="{9B968DEF-A3FA-4F7F-BC5F-EC77099FD92D}" type="datetimeFigureOut">
               <a:rPr lang="en-FI" smtClean="0"/>
-              <a:t>05/10/2025</a:t>
+              <a:t>06/10/2025</a:t>
             </a:fld>
             <a:endParaRPr lang="en-FI"/>
           </a:p>
@@ -2340,7 +2340,7 @@
           <a:p>
             <a:fld id="{9B968DEF-A3FA-4F7F-BC5F-EC77099FD92D}" type="datetimeFigureOut">
               <a:rPr lang="en-FI" smtClean="0"/>
-              <a:t>05/10/2025</a:t>
+              <a:t>06/10/2025</a:t>
             </a:fld>
             <a:endParaRPr lang="en-FI"/>
           </a:p>
@@ -2886,7 +2886,7 @@
           <a:p>
             <a:fld id="{9B968DEF-A3FA-4F7F-BC5F-EC77099FD92D}" type="datetimeFigureOut">
               <a:rPr lang="en-FI" smtClean="0"/>
-              <a:t>05/10/2025</a:t>
+              <a:t>06/10/2025</a:t>
             </a:fld>
             <a:endParaRPr lang="en-FI"/>
           </a:p>
@@ -3717,7 +3717,7 @@
           <a:p>
             <a:fld id="{9B968DEF-A3FA-4F7F-BC5F-EC77099FD92D}" type="datetimeFigureOut">
               <a:rPr lang="en-FI" smtClean="0"/>
-              <a:t>05/10/2025</a:t>
+              <a:t>06/10/2025</a:t>
             </a:fld>
             <a:endParaRPr lang="en-FI"/>
           </a:p>
@@ -3887,7 +3887,7 @@
           <a:p>
             <a:fld id="{9B968DEF-A3FA-4F7F-BC5F-EC77099FD92D}" type="datetimeFigureOut">
               <a:rPr lang="en-FI" smtClean="0"/>
-              <a:t>05/10/2025</a:t>
+              <a:t>06/10/2025</a:t>
             </a:fld>
             <a:endParaRPr lang="en-FI"/>
           </a:p>
@@ -4067,7 +4067,7 @@
           <a:p>
             <a:fld id="{9B968DEF-A3FA-4F7F-BC5F-EC77099FD92D}" type="datetimeFigureOut">
               <a:rPr lang="en-FI" smtClean="0"/>
-              <a:t>05/10/2025</a:t>
+              <a:t>06/10/2025</a:t>
             </a:fld>
             <a:endParaRPr lang="en-FI"/>
           </a:p>
@@ -4237,7 +4237,7 @@
           <a:p>
             <a:fld id="{9B968DEF-A3FA-4F7F-BC5F-EC77099FD92D}" type="datetimeFigureOut">
               <a:rPr lang="en-FI" smtClean="0"/>
-              <a:t>05/10/2025</a:t>
+              <a:t>06/10/2025</a:t>
             </a:fld>
             <a:endParaRPr lang="en-FI"/>
           </a:p>
@@ -4494,7 +4494,7 @@
           <a:p>
             <a:fld id="{9B968DEF-A3FA-4F7F-BC5F-EC77099FD92D}" type="datetimeFigureOut">
               <a:rPr lang="en-FI" smtClean="0"/>
-              <a:t>05/10/2025</a:t>
+              <a:t>06/10/2025</a:t>
             </a:fld>
             <a:endParaRPr lang="en-FI"/>
           </a:p>
@@ -4726,7 +4726,7 @@
           <a:p>
             <a:fld id="{9B968DEF-A3FA-4F7F-BC5F-EC77099FD92D}" type="datetimeFigureOut">
               <a:rPr lang="en-FI" smtClean="0"/>
-              <a:t>05/10/2025</a:t>
+              <a:t>06/10/2025</a:t>
             </a:fld>
             <a:endParaRPr lang="en-FI"/>
           </a:p>
@@ -5119,7 +5119,7 @@
           <a:p>
             <a:fld id="{9B968DEF-A3FA-4F7F-BC5F-EC77099FD92D}" type="datetimeFigureOut">
               <a:rPr lang="en-FI" smtClean="0"/>
-              <a:t>05/10/2025</a:t>
+              <a:t>06/10/2025</a:t>
             </a:fld>
             <a:endParaRPr lang="en-FI"/>
           </a:p>
@@ -5237,7 +5237,7 @@
           <a:p>
             <a:fld id="{9B968DEF-A3FA-4F7F-BC5F-EC77099FD92D}" type="datetimeFigureOut">
               <a:rPr lang="en-FI" smtClean="0"/>
-              <a:t>05/10/2025</a:t>
+              <a:t>06/10/2025</a:t>
             </a:fld>
             <a:endParaRPr lang="en-FI"/>
           </a:p>
@@ -5332,7 +5332,7 @@
           <a:p>
             <a:fld id="{9B968DEF-A3FA-4F7F-BC5F-EC77099FD92D}" type="datetimeFigureOut">
               <a:rPr lang="en-FI" smtClean="0"/>
-              <a:t>05/10/2025</a:t>
+              <a:t>06/10/2025</a:t>
             </a:fld>
             <a:endParaRPr lang="en-FI"/>
           </a:p>
@@ -5605,7 +5605,7 @@
           <a:p>
             <a:fld id="{9B968DEF-A3FA-4F7F-BC5F-EC77099FD92D}" type="datetimeFigureOut">
               <a:rPr lang="en-FI" smtClean="0"/>
-              <a:t>05/10/2025</a:t>
+              <a:t>06/10/2025</a:t>
             </a:fld>
             <a:endParaRPr lang="en-FI"/>
           </a:p>
@@ -5886,7 +5886,7 @@
           <a:p>
             <a:fld id="{9B968DEF-A3FA-4F7F-BC5F-EC77099FD92D}" type="datetimeFigureOut">
               <a:rPr lang="en-FI" smtClean="0"/>
-              <a:t>05/10/2025</a:t>
+              <a:t>06/10/2025</a:t>
             </a:fld>
             <a:endParaRPr lang="en-FI"/>
           </a:p>
@@ -6126,7 +6126,7 @@
           <a:p>
             <a:fld id="{9B968DEF-A3FA-4F7F-BC5F-EC77099FD92D}" type="datetimeFigureOut">
               <a:rPr lang="en-FI" smtClean="0"/>
-              <a:t>05/10/2025</a:t>
+              <a:t>06/10/2025</a:t>
             </a:fld>
             <a:endParaRPr lang="en-FI"/>
           </a:p>
@@ -6852,7 +6852,7 @@
                   </a:outerShdw>
                 </a:effectLst>
               </a:rPr>
-              <a:t>Guided Project by Sean Chandler</a:t>
+              <a:t>Project by Sean Chandler</a:t>
             </a:r>
           </a:p>
         </p:txBody>
@@ -7926,7 +7926,7 @@
                 <a:ea typeface="+mn-ea"/>
                 <a:cs typeface="+mn-cs"/>
               </a:rPr>
-              <a:t>Guided Project by Sean Chandler</a:t>
+              <a:t>Project by Sean Chandler</a:t>
             </a:r>
           </a:p>
         </p:txBody>
@@ -9221,7 +9221,7 @@
                 <a:ea typeface="+mn-ea"/>
                 <a:cs typeface="+mn-cs"/>
               </a:rPr>
-              <a:t>Guided Project by Sean Chandler</a:t>
+              <a:t>Project by Sean Chandler</a:t>
             </a:r>
           </a:p>
         </p:txBody>

</xml_diff>